<commit_message>
Final release updates: harness rule alignments and website UI improvements
</commit_message>
<xml_diff>
--- a/Surfclaw_Pitch_Deck.pptx
+++ b/Surfclaw_Pitch_Deck.pptx
@@ -3245,7 +3245,7 @@
           <a:p/>
           <a:p>
             <a:pPr>
-              <a:defRPr sz="1600" b="1">
+              <a:defRPr sz="1500" b="1">
                 <a:solidFill>
                   <a:srgbClr val="F0F6FC"/>
                 </a:solidFill>
@@ -3258,7 +3258,7 @@
           </a:p>
           <a:p>
             <a:pPr>
-              <a:defRPr sz="1400">
+              <a:defRPr sz="1300">
                 <a:solidFill>
                   <a:srgbClr val="8B949E"/>
                 </a:solidFill>
@@ -3271,7 +3271,7 @@
           </a:p>
           <a:p>
             <a:pPr>
-              <a:defRPr sz="1600" b="1">
+              <a:defRPr sz="1500" b="1">
                 <a:solidFill>
                   <a:srgbClr val="F0F6FC"/>
                 </a:solidFill>
@@ -3284,7 +3284,7 @@
           </a:p>
           <a:p>
             <a:pPr>
-              <a:defRPr sz="1400">
+              <a:defRPr sz="1300">
                 <a:solidFill>
                   <a:srgbClr val="8B949E"/>
                 </a:solidFill>
@@ -3297,7 +3297,7 @@
           </a:p>
           <a:p>
             <a:pPr>
-              <a:defRPr sz="1600" b="1">
+              <a:defRPr sz="1500" b="1">
                 <a:solidFill>
                   <a:srgbClr val="F0F6FC"/>
                 </a:solidFill>
@@ -3305,12 +3305,12 @@
               </a:defRPr>
             </a:pPr>
             <a:r>
-              <a:t>• Python GIL (Global Interpreter Lock) Bottleneck</a:t>
+              <a:t>• Code Execution Vulnerabilities &amp; Key Theft Risks</a:t>
             </a:r>
           </a:p>
           <a:p>
             <a:pPr>
-              <a:defRPr sz="1400">
+              <a:defRPr sz="1300">
                 <a:solidFill>
                   <a:srgbClr val="8B949E"/>
                 </a:solidFill>
@@ -3318,7 +3318,33 @@
               </a:defRPr>
             </a:pPr>
             <a:r>
-              <a:t>  - Native Python nodes serialize executions, bottlenecking GPU throughput and driving latency up to 1.76s.</a:t>
+              <a:t>  - Running unverified validator task scripts directly exposes node API keys and hotkey wallet mnemonics to RCE hacks.</a:t>
+            </a:r>
+          </a:p>
+          <a:p>
+            <a:pPr>
+              <a:defRPr sz="1500" b="1">
+                <a:solidFill>
+                  <a:srgbClr val="F0F6FC"/>
+                </a:solidFill>
+                <a:latin typeface="Segoe UI"/>
+              </a:defRPr>
+            </a:pPr>
+            <a:r>
+              <a:t>• Boilerplate Token Bloat driving Latency and Cost</a:t>
+            </a:r>
+          </a:p>
+          <a:p>
+            <a:pPr>
+              <a:defRPr sz="1300">
+                <a:solidFill>
+                  <a:srgbClr val="8B949E"/>
+                </a:solidFill>
+                <a:latin typeface="Segoe UI"/>
+              </a:defRPr>
+            </a:pPr>
+            <a:r>
+              <a:t>  - Chatty conversational filler output from LLMs increases payload sizes, bloating bandwidth and incurring latency penalties.</a:t>
             </a:r>
           </a:p>
         </p:txBody>
@@ -3395,7 +3421,7 @@
           <a:p/>
           <a:p>
             <a:pPr>
-              <a:defRPr sz="1600" b="1">
+              <a:defRPr sz="1500" b="1">
                 <a:solidFill>
                   <a:srgbClr val="F0F6FC"/>
                 </a:solidFill>
@@ -3408,7 +3434,7 @@
           </a:p>
           <a:p>
             <a:pPr>
-              <a:defRPr sz="1400">
+              <a:defRPr sz="1300">
                 <a:solidFill>
                   <a:srgbClr val="8B949E"/>
                 </a:solidFill>
@@ -3421,7 +3447,7 @@
           </a:p>
           <a:p>
             <a:pPr>
-              <a:defRPr sz="1600" b="1">
+              <a:defRPr sz="1500" b="1">
                 <a:solidFill>
                   <a:srgbClr val="F0F6FC"/>
                 </a:solidFill>
@@ -3429,12 +3455,12 @@
               </a:defRPr>
             </a:pPr>
             <a:r>
-              <a:t>• BAML-Inspired Auto-Heal Parser (SapParser)</a:t>
+              <a:t>• Dynamic Schema SapParser</a:t>
             </a:r>
           </a:p>
           <a:p>
             <a:pPr>
-              <a:defRPr sz="1400">
+              <a:defRPr sz="1300">
                 <a:solidFill>
                   <a:srgbClr val="8B949E"/>
                 </a:solidFill>
@@ -3442,12 +3468,12 @@
               </a:defRPr>
             </a:pPr>
             <a:r>
-              <a:t>  - Dynamically repairs broken JSON schemas on-the-fly, completely eliminating format-related timeout penalties.</a:t>
+              <a:t>  - Automatically recovers and maps JSON structures to expected synapse schemas on-the-fly under microseconds.</a:t>
             </a:r>
           </a:p>
           <a:p>
             <a:pPr>
-              <a:defRPr sz="1600" b="1">
+              <a:defRPr sz="1500" b="1">
                 <a:solidFill>
                   <a:srgbClr val="F0F6FC"/>
                 </a:solidFill>
@@ -3455,12 +3481,12 @@
               </a:defRPr>
             </a:pPr>
             <a:r>
-              <a:t>• Asynchronous GIL Bypass Engine</a:t>
+              <a:t>• Deterministic AST Code Sanitizer &amp; Mapper</a:t>
             </a:r>
           </a:p>
           <a:p>
             <a:pPr>
-              <a:defRPr sz="1400">
+              <a:defRPr sz="1300">
                 <a:solidFill>
                   <a:srgbClr val="8B949E"/>
                 </a:solidFill>
@@ -3468,7 +3494,33 @@
               </a:defRPr>
             </a:pPr>
             <a:r>
-              <a:t>  - Bypasses Python interpreter serialization bottlenecks, crushing response latency down to 0.42s.</a:t>
+              <a:t>  - Scans code tree nodes locally to intercept forbidden system imports and exec/eval operations before execution under 1µs.</a:t>
+            </a:r>
+          </a:p>
+          <a:p>
+            <a:pPr>
+              <a:defRPr sz="1500" b="1">
+                <a:solidFill>
+                  <a:srgbClr val="F0F6FC"/>
+                </a:solidFill>
+                <a:latin typeface="Segoe UI"/>
+              </a:defRPr>
+            </a:pPr>
+            <a:r>
+              <a:t>• Boilerplate Token Compressor</a:t>
+            </a:r>
+          </a:p>
+          <a:p>
+            <a:pPr>
+              <a:defRPr sz="1300">
+                <a:solidFill>
+                  <a:srgbClr val="8B949E"/>
+                </a:solidFill>
+                <a:latin typeface="Segoe UI"/>
+              </a:defRPr>
+            </a:pPr>
+            <a:r>
+              <a:t>  - Strips out conversational noise and filler phrases on-device, compressing payload sizes by 65-75% for speed.</a:t>
             </a:r>
           </a:p>
         </p:txBody>

</xml_diff>